<commit_message>
sync style of ppt between demo and index
</commit_message>
<xml_diff>
--- a/frontend/demo-assets/demo-export-sample.pptx
+++ b/frontend/demo-assets/demo-export-sample.pptx
@@ -1055,14 +1055,41 @@
       </p:grpSpPr>
       <p:sp>
         <p:nvSpPr>
-          <p:cNvPr id="2" name="Text 0"/>
-          <p:cNvSpPr/>
-          <p:nvPr/>
-        </p:nvSpPr>
-        <p:spPr>
-          <a:xfrm>
-            <a:off x="457200" y="182880"/>
-            <a:ext cx="10972800" cy="365760"/>
+          <p:cNvPr id="2" name="Shape 0"/>
+          <p:cNvSpPr/>
+          <p:nvPr/>
+        </p:nvSpPr>
+        <p:spPr>
+          <a:xfrm>
+            <a:off x="502920" y="347472"/>
+            <a:ext cx="1737360" cy="310896"/>
+          </a:xfrm>
+          <a:prstGeom prst="roundRect">
+            <a:avLst>
+              <a:gd name="adj" fmla="val 23529"/>
+            </a:avLst>
+          </a:prstGeom>
+          <a:solidFill>
+            <a:srgbClr val="E8F2E2"/>
+          </a:solidFill>
+          <a:ln w="12700">
+            <a:solidFill>
+              <a:srgbClr val="BFD2B7"/>
+            </a:solidFill>
+            <a:prstDash val="solid"/>
+          </a:ln>
+        </p:spPr>
+      </p:sp>
+      <p:sp>
+        <p:nvSpPr>
+          <p:cNvPr id="3" name="Text 1"/>
+          <p:cNvSpPr/>
+          <p:nvPr/>
+        </p:nvSpPr>
+        <p:spPr>
+          <a:xfrm>
+            <a:off x="749808" y="411480"/>
+            <a:ext cx="1234440" cy="109728"/>
           </a:xfrm>
           <a:prstGeom prst="rect">
             <a:avLst/>
@@ -1078,7 +1105,46 @@
               <a:buNone/>
             </a:pPr>
             <a:r>
-              <a:rPr lang="en-US" sz="1600" b="1" dirty="0">
+              <a:rPr lang="en-US" sz="1000" b="1" dirty="0">
+                <a:solidFill>
+                  <a:srgbClr val="5F8D52"/>
+                </a:solidFill>
+                <a:latin typeface="Yu Gothic" pitchFamily="34" charset="0"/>
+                <a:ea typeface="Yu Gothic" pitchFamily="34" charset="-122"/>
+                <a:cs typeface="Yu Gothic" pitchFamily="34" charset="-120"/>
+              </a:rPr>
+              <a:t>監査レポート</a:t>
+            </a:r>
+            <a:endParaRPr lang="en-US" sz="1000" dirty="0"/>
+          </a:p>
+        </p:txBody>
+      </p:sp>
+      <p:sp>
+        <p:nvSpPr>
+          <p:cNvPr id="4" name="Text 2"/>
+          <p:cNvSpPr/>
+          <p:nvPr/>
+        </p:nvSpPr>
+        <p:spPr>
+          <a:xfrm>
+            <a:off x="502920" y="822960"/>
+            <a:ext cx="7498080" cy="310896"/>
+          </a:xfrm>
+          <a:prstGeom prst="rect">
+            <a:avLst/>
+          </a:prstGeom>
+          <a:noFill/>
+          <a:ln/>
+        </p:spPr>
+        <p:txBody>
+          <a:bodyPr wrap="square" rtlCol="0" anchor="ctr"/>
+          <a:lstStyle/>
+          <a:p>
+            <a:pPr indent="0" marL="0">
+              <a:buNone/>
+            </a:pPr>
+            <a:r>
+              <a:rPr lang="en-US" sz="2100" b="1" dirty="0">
                 <a:solidFill>
                   <a:srgbClr val="1F2937"/>
                 </a:solidFill>
@@ -1088,20 +1154,20 @@
               </a:rPr>
               <a:t>F-101 2026年4月 定期巡回</a:t>
             </a:r>
-            <a:endParaRPr lang="en-US" sz="1600" dirty="0"/>
-          </a:p>
-        </p:txBody>
-      </p:sp>
-      <p:sp>
-        <p:nvSpPr>
-          <p:cNvPr id="3" name="Text 1"/>
-          <p:cNvSpPr/>
-          <p:nvPr/>
-        </p:nvSpPr>
-        <p:spPr>
-          <a:xfrm>
-            <a:off x="457200" y="640080"/>
-            <a:ext cx="10972800" cy="274320"/>
+            <a:endParaRPr lang="en-US" sz="2100" dirty="0"/>
+          </a:p>
+        </p:txBody>
+      </p:sp>
+      <p:sp>
+        <p:nvSpPr>
+          <p:cNvPr id="5" name="Text 3"/>
+          <p:cNvSpPr/>
+          <p:nvPr/>
+        </p:nvSpPr>
+        <p:spPr>
+          <a:xfrm>
+            <a:off x="502920" y="1124712"/>
+            <a:ext cx="7132320" cy="201168"/>
           </a:xfrm>
           <a:prstGeom prst="rect">
             <a:avLst/>
@@ -1119,7 +1185,7 @@
             <a:r>
               <a:rPr lang="en-US" sz="1100" dirty="0">
                 <a:solidFill>
-                  <a:srgbClr val="4B5563"/>
+                  <a:srgbClr val="6B7280"/>
                 </a:solidFill>
                 <a:latin typeface="Yu Gothic" pitchFamily="34" charset="0"/>
                 <a:ea typeface="Yu Gothic" pitchFamily="34" charset="-122"/>
@@ -1133,18 +1199,18 @@
       </p:sp>
       <p:sp>
         <p:nvSpPr>
-          <p:cNvPr id="4" name="Shape 2"/>
-          <p:cNvSpPr/>
-          <p:nvPr/>
-        </p:nvSpPr>
-        <p:spPr>
-          <a:xfrm>
-            <a:off x="457200" y="1051560"/>
-            <a:ext cx="7589520" cy="4754880"/>
+          <p:cNvPr id="6" name="Shape 4"/>
+          <p:cNvSpPr/>
+          <p:nvPr/>
+        </p:nvSpPr>
+        <p:spPr>
+          <a:xfrm>
+            <a:off x="502920" y="1417320"/>
+            <a:ext cx="6949440" cy="4480560"/>
           </a:xfrm>
           <a:prstGeom prst="roundRect">
             <a:avLst>
-              <a:gd name="adj" fmla="val 769"/>
+              <a:gd name="adj" fmla="val 1020"/>
             </a:avLst>
           </a:prstGeom>
           <a:solidFill>
@@ -1160,7 +1226,7 @@
       </p:sp>
       <p:pic>
         <p:nvPicPr>
-          <p:cNvPr id="5" name="Image 0" descr="preencoded.png">    </p:cNvPr>
+          <p:cNvPr id="7" name="Image 0" descr="preencoded.png">    </p:cNvPr>
           <p:cNvPicPr>
             <a:picLocks noChangeAspect="1"/>
           </p:cNvPicPr>
@@ -1179,8 +1245,8 @@
         </p:blipFill>
         <p:spPr>
           <a:xfrm>
-            <a:off x="457200" y="1051560"/>
-            <a:ext cx="7589520" cy="4754880"/>
+            <a:off x="502920" y="1417320"/>
+            <a:ext cx="6949440" cy="4480560"/>
           </a:xfrm>
           <a:prstGeom prst="rect">
             <a:avLst/>
@@ -1189,18 +1255,18 @@
       </p:pic>
       <p:sp>
         <p:nvSpPr>
-          <p:cNvPr id="6" name="Shape 3"/>
-          <p:cNvSpPr/>
-          <p:nvPr/>
-        </p:nvSpPr>
-        <p:spPr>
-          <a:xfrm>
-            <a:off x="8229600" y="1051560"/>
-            <a:ext cx="3474720" cy="4754880"/>
+          <p:cNvPr id="8" name="Shape 5"/>
+          <p:cNvSpPr/>
+          <p:nvPr/>
+        </p:nvSpPr>
+        <p:spPr>
+          <a:xfrm>
+            <a:off x="7726680" y="1417320"/>
+            <a:ext cx="3520440" cy="4480560"/>
           </a:xfrm>
           <a:prstGeom prst="roundRect">
             <a:avLst>
-              <a:gd name="adj" fmla="val 1053"/>
+              <a:gd name="adj" fmla="val 1299"/>
             </a:avLst>
           </a:prstGeom>
           <a:solidFill>
@@ -1216,14 +1282,53 @@
       </p:sp>
       <p:sp>
         <p:nvSpPr>
-          <p:cNvPr id="7" name="Text 4"/>
-          <p:cNvSpPr/>
-          <p:nvPr/>
-        </p:nvSpPr>
-        <p:spPr>
-          <a:xfrm>
-            <a:off x="8375904" y="1197864"/>
-            <a:ext cx="3182112" cy="4462272"/>
+          <p:cNvPr id="9" name="Text 6"/>
+          <p:cNvSpPr/>
+          <p:nvPr/>
+        </p:nvSpPr>
+        <p:spPr>
+          <a:xfrm>
+            <a:off x="7909560" y="1563624"/>
+            <a:ext cx="1188720" cy="146304"/>
+          </a:xfrm>
+          <a:prstGeom prst="rect">
+            <a:avLst/>
+          </a:prstGeom>
+          <a:noFill/>
+          <a:ln/>
+        </p:spPr>
+        <p:txBody>
+          <a:bodyPr wrap="square" rtlCol="0" anchor="ctr"/>
+          <a:lstStyle/>
+          <a:p>
+            <a:pPr indent="0" marL="0">
+              <a:buNone/>
+            </a:pPr>
+            <a:r>
+              <a:rPr lang="en-US" sz="1100" b="1" dirty="0">
+                <a:solidFill>
+                  <a:srgbClr val="5F8D52"/>
+                </a:solidFill>
+                <a:latin typeface="Yu Gothic" pitchFamily="34" charset="0"/>
+                <a:ea typeface="Yu Gothic" pitchFamily="34" charset="-122"/>
+                <a:cs typeface="Yu Gothic" pitchFamily="34" charset="-120"/>
+              </a:rPr>
+              <a:t>コメント</a:t>
+            </a:r>
+            <a:endParaRPr lang="en-US" sz="1100" dirty="0"/>
+          </a:p>
+        </p:txBody>
+      </p:sp>
+      <p:sp>
+        <p:nvSpPr>
+          <p:cNvPr id="10" name="Text 7"/>
+          <p:cNvSpPr/>
+          <p:nvPr/>
+        </p:nvSpPr>
+        <p:spPr>
+          <a:xfrm>
+            <a:off x="7909560" y="1837944"/>
+            <a:ext cx="3154680" cy="3767328"/>
           </a:xfrm>
           <a:prstGeom prst="rect">
             <a:avLst/>
@@ -1264,7 +1369,7 @@
                 <a:ea typeface="Yu Gothic" pitchFamily="34" charset="-122"/>
                 <a:cs typeface="Yu Gothic" pitchFamily="34" charset="-120"/>
               </a:rPr>
-              <a:t>2026/4/9 06:12 JST デモ利用者</a:t>
+              <a:t>2026/4/9 06:20 JST デモ利用者</a:t>
             </a:r>
             <a:endParaRPr lang="en-US" sz="1000" dirty="0"/>
           </a:p>
@@ -1304,7 +1409,7 @@
                 <a:ea typeface="Yu Gothic" pitchFamily="34" charset="-122"/>
                 <a:cs typeface="Yu Gothic" pitchFamily="34" charset="-120"/>
               </a:rPr>
-              <a:t>2026/4/9 06:42 JST 佐藤</a:t>
+              <a:t>2026/4/9 06:50 JST 佐藤</a:t>
             </a:r>
             <a:endParaRPr lang="en-US" sz="1000" dirty="0"/>
           </a:p>
@@ -1312,14 +1417,37 @@
       </p:sp>
       <p:sp>
         <p:nvSpPr>
-          <p:cNvPr id="8" name="Text 5"/>
-          <p:cNvSpPr/>
-          <p:nvPr/>
-        </p:nvSpPr>
-        <p:spPr>
-          <a:xfrm>
-            <a:off x="457200" y="6080760"/>
-            <a:ext cx="6217920" cy="182880"/>
+          <p:cNvPr id="11" name="Shape 8"/>
+          <p:cNvSpPr/>
+          <p:nvPr/>
+        </p:nvSpPr>
+        <p:spPr>
+          <a:xfrm>
+            <a:off x="502920" y="6236208"/>
+            <a:ext cx="10241280" cy="0"/>
+          </a:xfrm>
+          <a:prstGeom prst="line">
+            <a:avLst/>
+          </a:prstGeom>
+          <a:noFill/>
+          <a:ln w="12700">
+            <a:solidFill>
+              <a:srgbClr val="D8E0D2"/>
+            </a:solidFill>
+            <a:prstDash val="solid"/>
+          </a:ln>
+        </p:spPr>
+      </p:sp>
+      <p:sp>
+        <p:nvSpPr>
+          <p:cNvPr id="12" name="Text 9"/>
+          <p:cNvSpPr/>
+          <p:nvPr/>
+        </p:nvSpPr>
+        <p:spPr>
+          <a:xfrm>
+            <a:off x="530352" y="6291072"/>
+            <a:ext cx="9875520" cy="146304"/>
           </a:xfrm>
           <a:prstGeom prst="rect">
             <a:avLst/>
@@ -1343,7 +1471,7 @@
                 <a:ea typeface="Yu Gothic" pitchFamily="34" charset="-122"/>
                 <a:cs typeface="Yu Gothic" pitchFamily="34" charset="-120"/>
               </a:rPr>
-              <a:t>プラン: BASIC / 使用量: 0MB / 上限: 1024MB</a:t>
+              <a:t>プラン: BASIC / 使用量: 0MB / 上限: 1024MB / 1/3</a:t>
             </a:r>
             <a:endParaRPr lang="en-US" sz="800" dirty="0"/>
           </a:p>
@@ -1383,14 +1511,41 @@
       </p:grpSpPr>
       <p:sp>
         <p:nvSpPr>
-          <p:cNvPr id="2" name="Text 0"/>
-          <p:cNvSpPr/>
-          <p:nvPr/>
-        </p:nvSpPr>
-        <p:spPr>
-          <a:xfrm>
-            <a:off x="457200" y="182880"/>
-            <a:ext cx="10972800" cy="365760"/>
+          <p:cNvPr id="2" name="Shape 0"/>
+          <p:cNvSpPr/>
+          <p:nvPr/>
+        </p:nvSpPr>
+        <p:spPr>
+          <a:xfrm>
+            <a:off x="502920" y="347472"/>
+            <a:ext cx="1737360" cy="310896"/>
+          </a:xfrm>
+          <a:prstGeom prst="roundRect">
+            <a:avLst>
+              <a:gd name="adj" fmla="val 23529"/>
+            </a:avLst>
+          </a:prstGeom>
+          <a:solidFill>
+            <a:srgbClr val="E8F2E2"/>
+          </a:solidFill>
+          <a:ln w="12700">
+            <a:solidFill>
+              <a:srgbClr val="BFD2B7"/>
+            </a:solidFill>
+            <a:prstDash val="solid"/>
+          </a:ln>
+        </p:spPr>
+      </p:sp>
+      <p:sp>
+        <p:nvSpPr>
+          <p:cNvPr id="3" name="Text 1"/>
+          <p:cNvSpPr/>
+          <p:nvPr/>
+        </p:nvSpPr>
+        <p:spPr>
+          <a:xfrm>
+            <a:off x="749808" y="411480"/>
+            <a:ext cx="1234440" cy="109728"/>
           </a:xfrm>
           <a:prstGeom prst="rect">
             <a:avLst/>
@@ -1406,7 +1561,46 @@
               <a:buNone/>
             </a:pPr>
             <a:r>
-              <a:rPr lang="en-US" sz="1600" b="1" dirty="0">
+              <a:rPr lang="en-US" sz="1000" b="1" dirty="0">
+                <a:solidFill>
+                  <a:srgbClr val="5F8D52"/>
+                </a:solidFill>
+                <a:latin typeface="Yu Gothic" pitchFamily="34" charset="0"/>
+                <a:ea typeface="Yu Gothic" pitchFamily="34" charset="-122"/>
+                <a:cs typeface="Yu Gothic" pitchFamily="34" charset="-120"/>
+              </a:rPr>
+              <a:t>監査レポート</a:t>
+            </a:r>
+            <a:endParaRPr lang="en-US" sz="1000" dirty="0"/>
+          </a:p>
+        </p:txBody>
+      </p:sp>
+      <p:sp>
+        <p:nvSpPr>
+          <p:cNvPr id="4" name="Text 2"/>
+          <p:cNvSpPr/>
+          <p:nvPr/>
+        </p:nvSpPr>
+        <p:spPr>
+          <a:xfrm>
+            <a:off x="502920" y="822960"/>
+            <a:ext cx="7498080" cy="310896"/>
+          </a:xfrm>
+          <a:prstGeom prst="rect">
+            <a:avLst/>
+          </a:prstGeom>
+          <a:noFill/>
+          <a:ln/>
+        </p:spPr>
+        <p:txBody>
+          <a:bodyPr wrap="square" rtlCol="0" anchor="ctr"/>
+          <a:lstStyle/>
+          <a:p>
+            <a:pPr indent="0" marL="0">
+              <a:buNone/>
+            </a:pPr>
+            <a:r>
+              <a:rPr lang="en-US" sz="2100" b="1" dirty="0">
                 <a:solidFill>
                   <a:srgbClr val="1F2937"/>
                 </a:solidFill>
@@ -1416,20 +1610,20 @@
               </a:rPr>
               <a:t>F-101 2026年4月 定期巡回</a:t>
             </a:r>
-            <a:endParaRPr lang="en-US" sz="1600" dirty="0"/>
-          </a:p>
-        </p:txBody>
-      </p:sp>
-      <p:sp>
-        <p:nvSpPr>
-          <p:cNvPr id="3" name="Text 1"/>
-          <p:cNvSpPr/>
-          <p:nvPr/>
-        </p:nvSpPr>
-        <p:spPr>
-          <a:xfrm>
-            <a:off x="457200" y="640080"/>
-            <a:ext cx="10972800" cy="274320"/>
+            <a:endParaRPr lang="en-US" sz="2100" dirty="0"/>
+          </a:p>
+        </p:txBody>
+      </p:sp>
+      <p:sp>
+        <p:nvSpPr>
+          <p:cNvPr id="5" name="Text 3"/>
+          <p:cNvSpPr/>
+          <p:nvPr/>
+        </p:nvSpPr>
+        <p:spPr>
+          <a:xfrm>
+            <a:off x="502920" y="1124712"/>
+            <a:ext cx="7132320" cy="201168"/>
           </a:xfrm>
           <a:prstGeom prst="rect">
             <a:avLst/>
@@ -1447,7 +1641,7 @@
             <a:r>
               <a:rPr lang="en-US" sz="1100" dirty="0">
                 <a:solidFill>
-                  <a:srgbClr val="4B5563"/>
+                  <a:srgbClr val="6B7280"/>
                 </a:solidFill>
                 <a:latin typeface="Yu Gothic" pitchFamily="34" charset="0"/>
                 <a:ea typeface="Yu Gothic" pitchFamily="34" charset="-122"/>
@@ -1461,18 +1655,18 @@
       </p:sp>
       <p:sp>
         <p:nvSpPr>
-          <p:cNvPr id="4" name="Shape 2"/>
-          <p:cNvSpPr/>
-          <p:nvPr/>
-        </p:nvSpPr>
-        <p:spPr>
-          <a:xfrm>
-            <a:off x="457200" y="1051560"/>
-            <a:ext cx="7589520" cy="4754880"/>
+          <p:cNvPr id="6" name="Shape 4"/>
+          <p:cNvSpPr/>
+          <p:nvPr/>
+        </p:nvSpPr>
+        <p:spPr>
+          <a:xfrm>
+            <a:off x="502920" y="1417320"/>
+            <a:ext cx="6949440" cy="4480560"/>
           </a:xfrm>
           <a:prstGeom prst="roundRect">
             <a:avLst>
-              <a:gd name="adj" fmla="val 769"/>
+              <a:gd name="adj" fmla="val 1020"/>
             </a:avLst>
           </a:prstGeom>
           <a:solidFill>
@@ -1488,7 +1682,7 @@
       </p:sp>
       <p:pic>
         <p:nvPicPr>
-          <p:cNvPr id="5" name="Image 0" descr="preencoded.png">    </p:cNvPr>
+          <p:cNvPr id="7" name="Image 0" descr="preencoded.png">    </p:cNvPr>
           <p:cNvPicPr>
             <a:picLocks noChangeAspect="1"/>
           </p:cNvPicPr>
@@ -1507,8 +1701,8 @@
         </p:blipFill>
         <p:spPr>
           <a:xfrm>
-            <a:off x="457200" y="1051560"/>
-            <a:ext cx="7589520" cy="4754880"/>
+            <a:off x="502920" y="1417320"/>
+            <a:ext cx="6949440" cy="4480560"/>
           </a:xfrm>
           <a:prstGeom prst="rect">
             <a:avLst/>
@@ -1517,18 +1711,18 @@
       </p:pic>
       <p:sp>
         <p:nvSpPr>
-          <p:cNvPr id="6" name="Shape 3"/>
-          <p:cNvSpPr/>
-          <p:nvPr/>
-        </p:nvSpPr>
-        <p:spPr>
-          <a:xfrm>
-            <a:off x="8229600" y="1051560"/>
-            <a:ext cx="3474720" cy="4754880"/>
+          <p:cNvPr id="8" name="Shape 5"/>
+          <p:cNvSpPr/>
+          <p:nvPr/>
+        </p:nvSpPr>
+        <p:spPr>
+          <a:xfrm>
+            <a:off x="7726680" y="1417320"/>
+            <a:ext cx="3520440" cy="4480560"/>
           </a:xfrm>
           <a:prstGeom prst="roundRect">
             <a:avLst>
-              <a:gd name="adj" fmla="val 1053"/>
+              <a:gd name="adj" fmla="val 1299"/>
             </a:avLst>
           </a:prstGeom>
           <a:solidFill>
@@ -1544,14 +1738,53 @@
       </p:sp>
       <p:sp>
         <p:nvSpPr>
-          <p:cNvPr id="7" name="Text 4"/>
-          <p:cNvSpPr/>
-          <p:nvPr/>
-        </p:nvSpPr>
-        <p:spPr>
-          <a:xfrm>
-            <a:off x="8375904" y="1197864"/>
-            <a:ext cx="3182112" cy="4462272"/>
+          <p:cNvPr id="9" name="Text 6"/>
+          <p:cNvSpPr/>
+          <p:nvPr/>
+        </p:nvSpPr>
+        <p:spPr>
+          <a:xfrm>
+            <a:off x="7909560" y="1563624"/>
+            <a:ext cx="1188720" cy="146304"/>
+          </a:xfrm>
+          <a:prstGeom prst="rect">
+            <a:avLst/>
+          </a:prstGeom>
+          <a:noFill/>
+          <a:ln/>
+        </p:spPr>
+        <p:txBody>
+          <a:bodyPr wrap="square" rtlCol="0" anchor="ctr"/>
+          <a:lstStyle/>
+          <a:p>
+            <a:pPr indent="0" marL="0">
+              <a:buNone/>
+            </a:pPr>
+            <a:r>
+              <a:rPr lang="en-US" sz="1100" b="1" dirty="0">
+                <a:solidFill>
+                  <a:srgbClr val="5F8D52"/>
+                </a:solidFill>
+                <a:latin typeface="Yu Gothic" pitchFamily="34" charset="0"/>
+                <a:ea typeface="Yu Gothic" pitchFamily="34" charset="-122"/>
+                <a:cs typeface="Yu Gothic" pitchFamily="34" charset="-120"/>
+              </a:rPr>
+              <a:t>コメント</a:t>
+            </a:r>
+            <a:endParaRPr lang="en-US" sz="1100" dirty="0"/>
+          </a:p>
+        </p:txBody>
+      </p:sp>
+      <p:sp>
+        <p:nvSpPr>
+          <p:cNvPr id="10" name="Text 7"/>
+          <p:cNvSpPr/>
+          <p:nvPr/>
+        </p:nvSpPr>
+        <p:spPr>
+          <a:xfrm>
+            <a:off x="7909560" y="1837944"/>
+            <a:ext cx="3154680" cy="3767328"/>
           </a:xfrm>
           <a:prstGeom prst="rect">
             <a:avLst/>
@@ -1592,7 +1825,7 @@
                 <a:ea typeface="Yu Gothic" pitchFamily="34" charset="-122"/>
                 <a:cs typeface="Yu Gothic" pitchFamily="34" charset="-120"/>
               </a:rPr>
-              <a:t>2026/4/9 07:02 JST デモ利用者</a:t>
+              <a:t>2026/4/9 07:10 JST デモ利用者</a:t>
             </a:r>
             <a:endParaRPr lang="en-US" sz="1000" dirty="0"/>
           </a:p>
@@ -1600,14 +1833,37 @@
       </p:sp>
       <p:sp>
         <p:nvSpPr>
-          <p:cNvPr id="8" name="Text 5"/>
-          <p:cNvSpPr/>
-          <p:nvPr/>
-        </p:nvSpPr>
-        <p:spPr>
-          <a:xfrm>
-            <a:off x="457200" y="6080760"/>
-            <a:ext cx="6217920" cy="182880"/>
+          <p:cNvPr id="11" name="Shape 8"/>
+          <p:cNvSpPr/>
+          <p:nvPr/>
+        </p:nvSpPr>
+        <p:spPr>
+          <a:xfrm>
+            <a:off x="502920" y="6236208"/>
+            <a:ext cx="10241280" cy="0"/>
+          </a:xfrm>
+          <a:prstGeom prst="line">
+            <a:avLst/>
+          </a:prstGeom>
+          <a:noFill/>
+          <a:ln w="12700">
+            <a:solidFill>
+              <a:srgbClr val="D8E0D2"/>
+            </a:solidFill>
+            <a:prstDash val="solid"/>
+          </a:ln>
+        </p:spPr>
+      </p:sp>
+      <p:sp>
+        <p:nvSpPr>
+          <p:cNvPr id="12" name="Text 9"/>
+          <p:cNvSpPr/>
+          <p:nvPr/>
+        </p:nvSpPr>
+        <p:spPr>
+          <a:xfrm>
+            <a:off x="530352" y="6291072"/>
+            <a:ext cx="9875520" cy="146304"/>
           </a:xfrm>
           <a:prstGeom prst="rect">
             <a:avLst/>
@@ -1631,7 +1887,7 @@
                 <a:ea typeface="Yu Gothic" pitchFamily="34" charset="-122"/>
                 <a:cs typeface="Yu Gothic" pitchFamily="34" charset="-120"/>
               </a:rPr>
-              <a:t>プラン: BASIC / 使用量: 0MB / 上限: 1024MB</a:t>
+              <a:t>プラン: BASIC / 使用量: 0MB / 上限: 1024MB / 2/3</a:t>
             </a:r>
             <a:endParaRPr lang="en-US" sz="800" dirty="0"/>
           </a:p>
@@ -1671,14 +1927,41 @@
       </p:grpSpPr>
       <p:sp>
         <p:nvSpPr>
-          <p:cNvPr id="2" name="Text 0"/>
-          <p:cNvSpPr/>
-          <p:nvPr/>
-        </p:nvSpPr>
-        <p:spPr>
-          <a:xfrm>
-            <a:off x="457200" y="182880"/>
-            <a:ext cx="10972800" cy="365760"/>
+          <p:cNvPr id="2" name="Shape 0"/>
+          <p:cNvSpPr/>
+          <p:nvPr/>
+        </p:nvSpPr>
+        <p:spPr>
+          <a:xfrm>
+            <a:off x="502920" y="347472"/>
+            <a:ext cx="1737360" cy="310896"/>
+          </a:xfrm>
+          <a:prstGeom prst="roundRect">
+            <a:avLst>
+              <a:gd name="adj" fmla="val 23529"/>
+            </a:avLst>
+          </a:prstGeom>
+          <a:solidFill>
+            <a:srgbClr val="E8F2E2"/>
+          </a:solidFill>
+          <a:ln w="12700">
+            <a:solidFill>
+              <a:srgbClr val="BFD2B7"/>
+            </a:solidFill>
+            <a:prstDash val="solid"/>
+          </a:ln>
+        </p:spPr>
+      </p:sp>
+      <p:sp>
+        <p:nvSpPr>
+          <p:cNvPr id="3" name="Text 1"/>
+          <p:cNvSpPr/>
+          <p:nvPr/>
+        </p:nvSpPr>
+        <p:spPr>
+          <a:xfrm>
+            <a:off x="749808" y="411480"/>
+            <a:ext cx="1234440" cy="109728"/>
           </a:xfrm>
           <a:prstGeom prst="rect">
             <a:avLst/>
@@ -1694,7 +1977,46 @@
               <a:buNone/>
             </a:pPr>
             <a:r>
-              <a:rPr lang="en-US" sz="1600" b="1" dirty="0">
+              <a:rPr lang="en-US" sz="1000" b="1" dirty="0">
+                <a:solidFill>
+                  <a:srgbClr val="5F8D52"/>
+                </a:solidFill>
+                <a:latin typeface="Yu Gothic" pitchFamily="34" charset="0"/>
+                <a:ea typeface="Yu Gothic" pitchFamily="34" charset="-122"/>
+                <a:cs typeface="Yu Gothic" pitchFamily="34" charset="-120"/>
+              </a:rPr>
+              <a:t>監査レポート</a:t>
+            </a:r>
+            <a:endParaRPr lang="en-US" sz="1000" dirty="0"/>
+          </a:p>
+        </p:txBody>
+      </p:sp>
+      <p:sp>
+        <p:nvSpPr>
+          <p:cNvPr id="4" name="Text 2"/>
+          <p:cNvSpPr/>
+          <p:nvPr/>
+        </p:nvSpPr>
+        <p:spPr>
+          <a:xfrm>
+            <a:off x="502920" y="822960"/>
+            <a:ext cx="7498080" cy="310896"/>
+          </a:xfrm>
+          <a:prstGeom prst="rect">
+            <a:avLst/>
+          </a:prstGeom>
+          <a:noFill/>
+          <a:ln/>
+        </p:spPr>
+        <p:txBody>
+          <a:bodyPr wrap="square" rtlCol="0" anchor="ctr"/>
+          <a:lstStyle/>
+          <a:p>
+            <a:pPr indent="0" marL="0">
+              <a:buNone/>
+            </a:pPr>
+            <a:r>
+              <a:rPr lang="en-US" sz="2100" b="1" dirty="0">
                 <a:solidFill>
                   <a:srgbClr val="1F2937"/>
                 </a:solidFill>
@@ -1704,20 +2026,20 @@
               </a:rPr>
               <a:t>F-101 2026年4月 定期巡回</a:t>
             </a:r>
-            <a:endParaRPr lang="en-US" sz="1600" dirty="0"/>
-          </a:p>
-        </p:txBody>
-      </p:sp>
-      <p:sp>
-        <p:nvSpPr>
-          <p:cNvPr id="3" name="Text 1"/>
-          <p:cNvSpPr/>
-          <p:nvPr/>
-        </p:nvSpPr>
-        <p:spPr>
-          <a:xfrm>
-            <a:off x="457200" y="640080"/>
-            <a:ext cx="10972800" cy="274320"/>
+            <a:endParaRPr lang="en-US" sz="2100" dirty="0"/>
+          </a:p>
+        </p:txBody>
+      </p:sp>
+      <p:sp>
+        <p:nvSpPr>
+          <p:cNvPr id="5" name="Text 3"/>
+          <p:cNvSpPr/>
+          <p:nvPr/>
+        </p:nvSpPr>
+        <p:spPr>
+          <a:xfrm>
+            <a:off x="502920" y="1124712"/>
+            <a:ext cx="7132320" cy="201168"/>
           </a:xfrm>
           <a:prstGeom prst="rect">
             <a:avLst/>
@@ -1735,7 +2057,7 @@
             <a:r>
               <a:rPr lang="en-US" sz="1100" dirty="0">
                 <a:solidFill>
-                  <a:srgbClr val="4B5563"/>
+                  <a:srgbClr val="6B7280"/>
                 </a:solidFill>
                 <a:latin typeface="Yu Gothic" pitchFamily="34" charset="0"/>
                 <a:ea typeface="Yu Gothic" pitchFamily="34" charset="-122"/>
@@ -1749,18 +2071,18 @@
       </p:sp>
       <p:sp>
         <p:nvSpPr>
-          <p:cNvPr id="4" name="Shape 2"/>
-          <p:cNvSpPr/>
-          <p:nvPr/>
-        </p:nvSpPr>
-        <p:spPr>
-          <a:xfrm>
-            <a:off x="457200" y="1051560"/>
-            <a:ext cx="7589520" cy="4754880"/>
+          <p:cNvPr id="6" name="Shape 4"/>
+          <p:cNvSpPr/>
+          <p:nvPr/>
+        </p:nvSpPr>
+        <p:spPr>
+          <a:xfrm>
+            <a:off x="502920" y="1417320"/>
+            <a:ext cx="6949440" cy="4480560"/>
           </a:xfrm>
           <a:prstGeom prst="roundRect">
             <a:avLst>
-              <a:gd name="adj" fmla="val 769"/>
+              <a:gd name="adj" fmla="val 1020"/>
             </a:avLst>
           </a:prstGeom>
           <a:solidFill>
@@ -1776,7 +2098,7 @@
       </p:sp>
       <p:pic>
         <p:nvPicPr>
-          <p:cNvPr id="5" name="Image 0" descr="preencoded.png">    </p:cNvPr>
+          <p:cNvPr id="7" name="Image 0" descr="preencoded.png">    </p:cNvPr>
           <p:cNvPicPr>
             <a:picLocks noChangeAspect="1"/>
           </p:cNvPicPr>
@@ -1795,8 +2117,8 @@
         </p:blipFill>
         <p:spPr>
           <a:xfrm>
-            <a:off x="457200" y="1051560"/>
-            <a:ext cx="7589520" cy="4754880"/>
+            <a:off x="502920" y="1417320"/>
+            <a:ext cx="6949440" cy="4480560"/>
           </a:xfrm>
           <a:prstGeom prst="rect">
             <a:avLst/>
@@ -1805,18 +2127,18 @@
       </p:pic>
       <p:sp>
         <p:nvSpPr>
-          <p:cNvPr id="6" name="Shape 3"/>
-          <p:cNvSpPr/>
-          <p:nvPr/>
-        </p:nvSpPr>
-        <p:spPr>
-          <a:xfrm>
-            <a:off x="8229600" y="1051560"/>
-            <a:ext cx="3474720" cy="4754880"/>
+          <p:cNvPr id="8" name="Shape 5"/>
+          <p:cNvSpPr/>
+          <p:nvPr/>
+        </p:nvSpPr>
+        <p:spPr>
+          <a:xfrm>
+            <a:off x="7726680" y="1417320"/>
+            <a:ext cx="3520440" cy="4480560"/>
           </a:xfrm>
           <a:prstGeom prst="roundRect">
             <a:avLst>
-              <a:gd name="adj" fmla="val 1053"/>
+              <a:gd name="adj" fmla="val 1299"/>
             </a:avLst>
           </a:prstGeom>
           <a:solidFill>
@@ -1832,14 +2154,53 @@
       </p:sp>
       <p:sp>
         <p:nvSpPr>
-          <p:cNvPr id="7" name="Text 4"/>
-          <p:cNvSpPr/>
-          <p:nvPr/>
-        </p:nvSpPr>
-        <p:spPr>
-          <a:xfrm>
-            <a:off x="8375904" y="1197864"/>
-            <a:ext cx="3182112" cy="4462272"/>
+          <p:cNvPr id="9" name="Text 6"/>
+          <p:cNvSpPr/>
+          <p:nvPr/>
+        </p:nvSpPr>
+        <p:spPr>
+          <a:xfrm>
+            <a:off x="7909560" y="1563624"/>
+            <a:ext cx="1188720" cy="146304"/>
+          </a:xfrm>
+          <a:prstGeom prst="rect">
+            <a:avLst/>
+          </a:prstGeom>
+          <a:noFill/>
+          <a:ln/>
+        </p:spPr>
+        <p:txBody>
+          <a:bodyPr wrap="square" rtlCol="0" anchor="ctr"/>
+          <a:lstStyle/>
+          <a:p>
+            <a:pPr indent="0" marL="0">
+              <a:buNone/>
+            </a:pPr>
+            <a:r>
+              <a:rPr lang="en-US" sz="1100" b="1" dirty="0">
+                <a:solidFill>
+                  <a:srgbClr val="5F8D52"/>
+                </a:solidFill>
+                <a:latin typeface="Yu Gothic" pitchFamily="34" charset="0"/>
+                <a:ea typeface="Yu Gothic" pitchFamily="34" charset="-122"/>
+                <a:cs typeface="Yu Gothic" pitchFamily="34" charset="-120"/>
+              </a:rPr>
+              <a:t>コメント</a:t>
+            </a:r>
+            <a:endParaRPr lang="en-US" sz="1100" dirty="0"/>
+          </a:p>
+        </p:txBody>
+      </p:sp>
+      <p:sp>
+        <p:nvSpPr>
+          <p:cNvPr id="10" name="Text 7"/>
+          <p:cNvSpPr/>
+          <p:nvPr/>
+        </p:nvSpPr>
+        <p:spPr>
+          <a:xfrm>
+            <a:off x="7909560" y="1837944"/>
+            <a:ext cx="3154680" cy="3767328"/>
           </a:xfrm>
           <a:prstGeom prst="rect">
             <a:avLst/>
@@ -1871,14 +2232,37 @@
       </p:sp>
       <p:sp>
         <p:nvSpPr>
-          <p:cNvPr id="8" name="Text 5"/>
-          <p:cNvSpPr/>
-          <p:nvPr/>
-        </p:nvSpPr>
-        <p:spPr>
-          <a:xfrm>
-            <a:off x="457200" y="6080760"/>
-            <a:ext cx="6217920" cy="182880"/>
+          <p:cNvPr id="11" name="Shape 8"/>
+          <p:cNvSpPr/>
+          <p:nvPr/>
+        </p:nvSpPr>
+        <p:spPr>
+          <a:xfrm>
+            <a:off x="502920" y="6236208"/>
+            <a:ext cx="10241280" cy="0"/>
+          </a:xfrm>
+          <a:prstGeom prst="line">
+            <a:avLst/>
+          </a:prstGeom>
+          <a:noFill/>
+          <a:ln w="12700">
+            <a:solidFill>
+              <a:srgbClr val="D8E0D2"/>
+            </a:solidFill>
+            <a:prstDash val="solid"/>
+          </a:ln>
+        </p:spPr>
+      </p:sp>
+      <p:sp>
+        <p:nvSpPr>
+          <p:cNvPr id="12" name="Text 9"/>
+          <p:cNvSpPr/>
+          <p:nvPr/>
+        </p:nvSpPr>
+        <p:spPr>
+          <a:xfrm>
+            <a:off x="530352" y="6291072"/>
+            <a:ext cx="9875520" cy="146304"/>
           </a:xfrm>
           <a:prstGeom prst="rect">
             <a:avLst/>
@@ -1902,7 +2286,7 @@
                 <a:ea typeface="Yu Gothic" pitchFamily="34" charset="-122"/>
                 <a:cs typeface="Yu Gothic" pitchFamily="34" charset="-120"/>
               </a:rPr>
-              <a:t>プラン: BASIC / 使用量: 0MB / 上限: 1024MB</a:t>
+              <a:t>プラン: BASIC / 使用量: 0MB / 上限: 1024MB / 3/3</a:t>
             </a:r>
             <a:endParaRPr lang="en-US" sz="800" dirty="0"/>
           </a:p>

</xml_diff>